<commit_message>
Simplify closing slide to a two-column close
Restructures the closing slide for clarity — less to take in at once:

- Left: the six-month plan as a vertical timeline (numbered periwinkle
  nodes on a connector line), read top to bottom.
- Right, stacked: the dark North Star anchor; how it shows up in the
  operational cycle (Reviewed -> Acted on -> Earlier); the renewal-story
  payoff card.

Also replaces the passive North Star wording "Median weeks earlier that
meaningful decline is reviewed" with the active, plain-language
"How early we catch meaningful decline" — a question the big
"Week 2, not Week 12" answers directly.

Co-Authored-By: Claude Opus 4.8 <noreply@anthropic.com>
Claude-Session: https://claude.ai/code/session_018jpa1FjWwPJmNvbN8n8uhp
</commit_message>
<xml_diff>
--- a/rocky-mountain/closing-slide.pptx
+++ b/rocky-mountain/closing-slide.pptx
@@ -502,7 +502,7 @@
           <a:p>
             <a:r>
               <a:rPr lang="en-US" dirty="0"/>
-              <a:t>Closing slide, rebuilt as a closing argument. Reading path: title → North Star (dark anchor) → success ladder → renewal story. North Star 'Week 2, not Week 12' is the single biggest phrase. All figures are illustrative — replace N / M and specifics with real pilot numbers.</a:t>
+              <a:t>Closing slide. Two-column read: LEFT is the six-month plan as a vertical timeline; RIGHT is the payoff, stacked — the North Star anchor, how it shows up in the operational cycle (Reviewed -&gt; Acted on -&gt; Earlier), and the renewal story. 'Week 2, not Week 12' is the single biggest phrase. All figures are illustrative — replace specifics with real pilot numbers.</a:t>
             </a:r>
             <a:endParaRPr lang="en-US" dirty="0"/>
           </a:p>
@@ -1026,20 +1026,16 @@
         </p:nvSpPr>
         <p:spPr>
           <a:xfrm>
-            <a:off x="777240" y="1810512"/>
-            <a:ext cx="5669280" cy="774192"/>
-          </a:xfrm>
-          <a:prstGeom prst="roundRect">
-            <a:avLst>
-              <a:gd name="adj" fmla="val 14173"/>
-            </a:avLst>
-          </a:prstGeom>
-          <a:solidFill>
-            <a:srgbClr val="F4F4F4"/>
-          </a:solidFill>
-          <a:ln w="12700">
+            <a:off x="1005840" y="2313432"/>
+            <a:ext cx="0" cy="3200400"/>
+          </a:xfrm>
+          <a:prstGeom prst="line">
+            <a:avLst/>
+          </a:prstGeom>
+          <a:noFill/>
+          <a:ln w="19050">
             <a:solidFill>
-              <a:srgbClr val="E6E6E6"/>
+              <a:srgbClr val="D9DCEA"/>
             </a:solidFill>
             <a:prstDash val="solid"/>
           </a:ln>
@@ -1047,34 +1043,154 @@
       </p:sp>
       <p:sp>
         <p:nvSpPr>
-          <p:cNvPr id="7" name="Shape 5"/>
-          <p:cNvSpPr/>
-          <p:nvPr/>
-        </p:nvSpPr>
-        <p:spPr>
-          <a:xfrm>
-            <a:off x="996696" y="1978152"/>
-            <a:ext cx="438912" cy="438912"/>
+          <p:cNvPr id="7" name="Text 5"/>
+          <p:cNvSpPr/>
+          <p:nvPr/>
+        </p:nvSpPr>
+        <p:spPr>
+          <a:xfrm>
+            <a:off x="1508760" y="2011680"/>
+            <a:ext cx="3840480" cy="201168"/>
+          </a:xfrm>
+          <a:prstGeom prst="rect">
+            <a:avLst/>
+          </a:prstGeom>
+          <a:noFill/>
+          <a:ln/>
+        </p:spPr>
+        <p:txBody>
+          <a:bodyPr wrap="square" lIns="0" tIns="0" rIns="0" bIns="0" rtlCol="0" anchor="t"/>
+          <a:lstStyle/>
+          <a:p>
+            <a:pPr algn="l" indent="0" marL="0">
+              <a:buNone/>
+            </a:pPr>
+            <a:r>
+              <a:rPr lang="en-US" sz="950" b="1" spc="150" kern="0" dirty="0">
+                <a:solidFill>
+                  <a:srgbClr val="5A6CE6"/>
+                </a:solidFill>
+                <a:latin typeface="Calibri" pitchFamily="34" charset="0"/>
+                <a:ea typeface="Calibri" pitchFamily="34" charset="-122"/>
+                <a:cs typeface="Calibri" pitchFamily="34" charset="-120"/>
+              </a:rPr>
+              <a:t>MONTHS 1–2</a:t>
+            </a:r>
+            <a:endParaRPr lang="en-US" sz="950" dirty="0"/>
+          </a:p>
+        </p:txBody>
+      </p:sp>
+      <p:sp>
+        <p:nvSpPr>
+          <p:cNvPr id="8" name="Text 6"/>
+          <p:cNvSpPr/>
+          <p:nvPr/>
+        </p:nvSpPr>
+        <p:spPr>
+          <a:xfrm>
+            <a:off x="1508760" y="2194560"/>
+            <a:ext cx="3840480" cy="274320"/>
+          </a:xfrm>
+          <a:prstGeom prst="rect">
+            <a:avLst/>
+          </a:prstGeom>
+          <a:noFill/>
+          <a:ln/>
+        </p:spPr>
+        <p:txBody>
+          <a:bodyPr wrap="square" lIns="0" tIns="0" rIns="0" bIns="0" rtlCol="0" anchor="t"/>
+          <a:lstStyle/>
+          <a:p>
+            <a:pPr algn="l" indent="0" marL="0">
+              <a:buNone/>
+            </a:pPr>
+            <a:r>
+              <a:rPr lang="en-US" sz="1600" b="1" dirty="0">
+                <a:solidFill>
+                  <a:srgbClr val="181818"/>
+                </a:solidFill>
+                <a:latin typeface="Calibri" pitchFamily="34" charset="0"/>
+                <a:ea typeface="Calibri" pitchFamily="34" charset="-122"/>
+                <a:cs typeface="Calibri" pitchFamily="34" charset="-120"/>
+              </a:rPr>
+              <a:t>Prove the signal</a:t>
+            </a:r>
+            <a:endParaRPr lang="en-US" sz="1600" dirty="0"/>
+          </a:p>
+        </p:txBody>
+      </p:sp>
+      <p:sp>
+        <p:nvSpPr>
+          <p:cNvPr id="9" name="Text 7"/>
+          <p:cNvSpPr/>
+          <p:nvPr/>
+        </p:nvSpPr>
+        <p:spPr>
+          <a:xfrm>
+            <a:off x="1508760" y="2487168"/>
+            <a:ext cx="3840480" cy="457200"/>
+          </a:xfrm>
+          <a:prstGeom prst="rect">
+            <a:avLst/>
+          </a:prstGeom>
+          <a:noFill/>
+          <a:ln/>
+        </p:spPr>
+        <p:txBody>
+          <a:bodyPr wrap="square" lIns="0" tIns="0" rIns="0" bIns="0" rtlCol="0" anchor="t"/>
+          <a:lstStyle/>
+          <a:p>
+            <a:pPr algn="l" indent="0" marL="0">
+              <a:lnSpc>
+                <a:spcPct val="110000"/>
+              </a:lnSpc>
+              <a:buNone/>
+            </a:pPr>
+            <a:r>
+              <a:rPr lang="en-US" sz="1150" dirty="0">
+                <a:solidFill>
+                  <a:srgbClr val="8E8E8E"/>
+                </a:solidFill>
+                <a:latin typeface="Calibri" pitchFamily="34" charset="0"/>
+                <a:ea typeface="Calibri" pitchFamily="34" charset="-122"/>
+                <a:cs typeface="Calibri" pitchFamily="34" charset="-120"/>
+              </a:rPr>
+              <a:t>Replay known care changes against Teton history.</a:t>
+            </a:r>
+            <a:endParaRPr lang="en-US" sz="1150" dirty="0"/>
+          </a:p>
+        </p:txBody>
+      </p:sp>
+      <p:sp>
+        <p:nvSpPr>
+          <p:cNvPr id="10" name="Shape 8"/>
+          <p:cNvSpPr/>
+          <p:nvPr/>
+        </p:nvSpPr>
+        <p:spPr>
+          <a:xfrm>
+            <a:off x="804672" y="2112264"/>
+            <a:ext cx="402336" cy="402336"/>
           </a:xfrm>
           <a:prstGeom prst="ellipse">
             <a:avLst/>
           </a:prstGeom>
           <a:solidFill>
-            <a:srgbClr val="181818"/>
-          </a:solidFill>
-          <a:ln/>
-        </p:spPr>
-      </p:sp>
-      <p:sp>
-        <p:nvSpPr>
-          <p:cNvPr id="8" name="Text 6"/>
-          <p:cNvSpPr/>
-          <p:nvPr/>
-        </p:nvSpPr>
-        <p:spPr>
-          <a:xfrm>
-            <a:off x="996696" y="1978152"/>
-            <a:ext cx="438912" cy="438912"/>
+            <a:srgbClr val="5A6CE6"/>
+          </a:solidFill>
+          <a:ln/>
+        </p:spPr>
+      </p:sp>
+      <p:sp>
+        <p:nvSpPr>
+          <p:cNvPr id="11" name="Text 9"/>
+          <p:cNvSpPr/>
+          <p:nvPr/>
+        </p:nvSpPr>
+        <p:spPr>
+          <a:xfrm>
+            <a:off x="804672" y="2112264"/>
+            <a:ext cx="402336" cy="402336"/>
           </a:xfrm>
           <a:prstGeom prst="rect">
             <a:avLst/>
@@ -1090,7 +1206,7 @@
               <a:buNone/>
             </a:pPr>
             <a:r>
-              <a:rPr lang="en-US" sz="1700" b="1" dirty="0">
+              <a:rPr lang="en-US" sz="1300" b="1" dirty="0">
                 <a:solidFill>
                   <a:srgbClr val="FFFFFF"/>
                 </a:solidFill>
@@ -1100,19 +1216,19 @@
               </a:rPr>
               <a:t>1</a:t>
             </a:r>
-            <a:endParaRPr lang="en-US" sz="1700" dirty="0"/>
-          </a:p>
-        </p:txBody>
-      </p:sp>
-      <p:sp>
-        <p:nvSpPr>
-          <p:cNvPr id="9" name="Text 7"/>
-          <p:cNvSpPr/>
-          <p:nvPr/>
-        </p:nvSpPr>
-        <p:spPr>
-          <a:xfrm>
-            <a:off x="1645920" y="1929384"/>
+            <a:endParaRPr lang="en-US" sz="1300" dirty="0"/>
+          </a:p>
+        </p:txBody>
+      </p:sp>
+      <p:sp>
+        <p:nvSpPr>
+          <p:cNvPr id="12" name="Text 10"/>
+          <p:cNvSpPr/>
+          <p:nvPr/>
+        </p:nvSpPr>
+        <p:spPr>
+          <a:xfrm>
+            <a:off x="1508760" y="3611880"/>
             <a:ext cx="3840480" cy="201168"/>
           </a:xfrm>
           <a:prstGeom prst="rect">
@@ -1129,7 +1245,88 @@
               <a:buNone/>
             </a:pPr>
             <a:r>
-              <a:rPr lang="en-US" sz="900" b="1" spc="150" kern="0" dirty="0">
+              <a:rPr lang="en-US" sz="950" b="1" spc="150" kern="0" dirty="0">
+                <a:solidFill>
+                  <a:srgbClr val="5A6CE6"/>
+                </a:solidFill>
+                <a:latin typeface="Calibri" pitchFamily="34" charset="0"/>
+                <a:ea typeface="Calibri" pitchFamily="34" charset="-122"/>
+                <a:cs typeface="Calibri" pitchFamily="34" charset="-120"/>
+              </a:rPr>
+              <a:t>MONTHS 2–4</a:t>
+            </a:r>
+            <a:endParaRPr lang="en-US" sz="950" dirty="0"/>
+          </a:p>
+        </p:txBody>
+      </p:sp>
+      <p:sp>
+        <p:nvSpPr>
+          <p:cNvPr id="13" name="Text 11"/>
+          <p:cNvSpPr/>
+          <p:nvPr/>
+        </p:nvSpPr>
+        <p:spPr>
+          <a:xfrm>
+            <a:off x="1508760" y="3794760"/>
+            <a:ext cx="3840480" cy="274320"/>
+          </a:xfrm>
+          <a:prstGeom prst="rect">
+            <a:avLst/>
+          </a:prstGeom>
+          <a:noFill/>
+          <a:ln/>
+        </p:spPr>
+        <p:txBody>
+          <a:bodyPr wrap="square" lIns="0" tIns="0" rIns="0" bIns="0" rtlCol="0" anchor="t"/>
+          <a:lstStyle/>
+          <a:p>
+            <a:pPr algn="l" indent="0" marL="0">
+              <a:buNone/>
+            </a:pPr>
+            <a:r>
+              <a:rPr lang="en-US" sz="1600" b="1" dirty="0">
+                <a:solidFill>
+                  <a:srgbClr val="181818"/>
+                </a:solidFill>
+                <a:latin typeface="Calibri" pitchFamily="34" charset="0"/>
+                <a:ea typeface="Calibri" pitchFamily="34" charset="-122"/>
+                <a:cs typeface="Calibri" pitchFamily="34" charset="-120"/>
+              </a:rPr>
+              <a:t>Prove the workflow</a:t>
+            </a:r>
+            <a:endParaRPr lang="en-US" sz="1600" dirty="0"/>
+          </a:p>
+        </p:txBody>
+      </p:sp>
+      <p:sp>
+        <p:nvSpPr>
+          <p:cNvPr id="14" name="Text 12"/>
+          <p:cNvSpPr/>
+          <p:nvPr/>
+        </p:nvSpPr>
+        <p:spPr>
+          <a:xfrm>
+            <a:off x="1508760" y="4087368"/>
+            <a:ext cx="3840480" cy="457200"/>
+          </a:xfrm>
+          <a:prstGeom prst="rect">
+            <a:avLst/>
+          </a:prstGeom>
+          <a:noFill/>
+          <a:ln/>
+        </p:spPr>
+        <p:txBody>
+          <a:bodyPr wrap="square" lIns="0" tIns="0" rIns="0" bIns="0" rtlCol="0" anchor="t"/>
+          <a:lstStyle/>
+          <a:p>
+            <a:pPr algn="l" indent="0" marL="0">
+              <a:lnSpc>
+                <a:spcPct val="110000"/>
+              </a:lnSpc>
+              <a:buNone/>
+            </a:pPr>
+            <a:r>
+              <a:rPr lang="en-US" sz="1150" dirty="0">
                 <a:solidFill>
                   <a:srgbClr val="8E8E8E"/>
                 </a:solidFill>
@@ -1137,22 +1334,81 @@
                 <a:ea typeface="Calibri" pitchFamily="34" charset="-122"/>
                 <a:cs typeface="Calibri" pitchFamily="34" charset="-120"/>
               </a:rPr>
-              <a:t>MONTHS 1–2</a:t>
-            </a:r>
-            <a:endParaRPr lang="en-US" sz="900" dirty="0"/>
-          </a:p>
-        </p:txBody>
-      </p:sp>
-      <p:sp>
-        <p:nvSpPr>
-          <p:cNvPr id="10" name="Text 8"/>
-          <p:cNvSpPr/>
-          <p:nvPr/>
-        </p:nvSpPr>
-        <p:spPr>
-          <a:xfrm>
-            <a:off x="1645920" y="2103120"/>
-            <a:ext cx="4023360" cy="274320"/>
+              <a:t>Run weekly candidates by hand with 1–2 partners.</a:t>
+            </a:r>
+            <a:endParaRPr lang="en-US" sz="1150" dirty="0"/>
+          </a:p>
+        </p:txBody>
+      </p:sp>
+      <p:sp>
+        <p:nvSpPr>
+          <p:cNvPr id="15" name="Shape 13"/>
+          <p:cNvSpPr/>
+          <p:nvPr/>
+        </p:nvSpPr>
+        <p:spPr>
+          <a:xfrm>
+            <a:off x="804672" y="3712464"/>
+            <a:ext cx="402336" cy="402336"/>
+          </a:xfrm>
+          <a:prstGeom prst="ellipse">
+            <a:avLst/>
+          </a:prstGeom>
+          <a:solidFill>
+            <a:srgbClr val="5A6CE6"/>
+          </a:solidFill>
+          <a:ln/>
+        </p:spPr>
+      </p:sp>
+      <p:sp>
+        <p:nvSpPr>
+          <p:cNvPr id="16" name="Text 14"/>
+          <p:cNvSpPr/>
+          <p:nvPr/>
+        </p:nvSpPr>
+        <p:spPr>
+          <a:xfrm>
+            <a:off x="804672" y="3712464"/>
+            <a:ext cx="402336" cy="402336"/>
+          </a:xfrm>
+          <a:prstGeom prst="rect">
+            <a:avLst/>
+          </a:prstGeom>
+          <a:noFill/>
+          <a:ln/>
+        </p:spPr>
+        <p:txBody>
+          <a:bodyPr wrap="square" lIns="0" tIns="0" rIns="0" bIns="0" rtlCol="0" anchor="ctr"/>
+          <a:lstStyle/>
+          <a:p>
+            <a:pPr algn="ctr" indent="0" marL="0">
+              <a:buNone/>
+            </a:pPr>
+            <a:r>
+              <a:rPr lang="en-US" sz="1300" b="1" dirty="0">
+                <a:solidFill>
+                  <a:srgbClr val="FFFFFF"/>
+                </a:solidFill>
+                <a:latin typeface="Calibri" pitchFamily="34" charset="0"/>
+                <a:ea typeface="Calibri" pitchFamily="34" charset="-122"/>
+                <a:cs typeface="Calibri" pitchFamily="34" charset="-120"/>
+              </a:rPr>
+              <a:t>2</a:t>
+            </a:r>
+            <a:endParaRPr lang="en-US" sz="1300" dirty="0"/>
+          </a:p>
+        </p:txBody>
+      </p:sp>
+      <p:sp>
+        <p:nvSpPr>
+          <p:cNvPr id="17" name="Text 15"/>
+          <p:cNvSpPr/>
+          <p:nvPr/>
+        </p:nvSpPr>
+        <p:spPr>
+          <a:xfrm>
+            <a:off x="1508760" y="5212080"/>
+            <a:ext cx="3840480" cy="201168"/>
           </a:xfrm>
           <a:prstGeom prst="rect">
             <a:avLst/>
@@ -1168,7 +1424,46 @@
               <a:buNone/>
             </a:pPr>
             <a:r>
-              <a:rPr lang="en-US" sz="1550" b="1" dirty="0">
+              <a:rPr lang="en-US" sz="950" b="1" spc="150" kern="0" dirty="0">
+                <a:solidFill>
+                  <a:srgbClr val="5A6CE6"/>
+                </a:solidFill>
+                <a:latin typeface="Calibri" pitchFamily="34" charset="0"/>
+                <a:ea typeface="Calibri" pitchFamily="34" charset="-122"/>
+                <a:cs typeface="Calibri" pitchFamily="34" charset="-120"/>
+              </a:rPr>
+              <a:t>MONTHS 4–6</a:t>
+            </a:r>
+            <a:endParaRPr lang="en-US" sz="950" dirty="0"/>
+          </a:p>
+        </p:txBody>
+      </p:sp>
+      <p:sp>
+        <p:nvSpPr>
+          <p:cNvPr id="18" name="Text 16"/>
+          <p:cNvSpPr/>
+          <p:nvPr/>
+        </p:nvSpPr>
+        <p:spPr>
+          <a:xfrm>
+            <a:off x="1508760" y="5394960"/>
+            <a:ext cx="3840480" cy="274320"/>
+          </a:xfrm>
+          <a:prstGeom prst="rect">
+            <a:avLst/>
+          </a:prstGeom>
+          <a:noFill/>
+          <a:ln/>
+        </p:spPr>
+        <p:txBody>
+          <a:bodyPr wrap="square" lIns="0" tIns="0" rIns="0" bIns="0" rtlCol="0" anchor="t"/>
+          <a:lstStyle/>
+          <a:p>
+            <a:pPr algn="l" indent="0" marL="0">
+              <a:buNone/>
+            </a:pPr>
+            <a:r>
+              <a:rPr lang="en-US" sz="1600" b="1" dirty="0">
                 <a:solidFill>
                   <a:srgbClr val="181818"/>
                 </a:solidFill>
@@ -1176,22 +1471,22 @@
                 <a:ea typeface="Calibri" pitchFamily="34" charset="-122"/>
                 <a:cs typeface="Calibri" pitchFamily="34" charset="-120"/>
               </a:rPr>
-              <a:t>Prove the signal</a:t>
-            </a:r>
-            <a:endParaRPr lang="en-US" sz="1550" dirty="0"/>
-          </a:p>
-        </p:txBody>
-      </p:sp>
-      <p:sp>
-        <p:nvSpPr>
-          <p:cNvPr id="11" name="Text 9"/>
-          <p:cNvSpPr/>
-          <p:nvPr/>
-        </p:nvSpPr>
-        <p:spPr>
-          <a:xfrm>
-            <a:off x="1645920" y="2359152"/>
-            <a:ext cx="4069080" cy="219456"/>
+              <a:t>Automate the loop</a:t>
+            </a:r>
+            <a:endParaRPr lang="en-US" sz="1600" dirty="0"/>
+          </a:p>
+        </p:txBody>
+      </p:sp>
+      <p:sp>
+        <p:nvSpPr>
+          <p:cNvPr id="19" name="Text 17"/>
+          <p:cNvSpPr/>
+          <p:nvPr/>
+        </p:nvSpPr>
+        <p:spPr>
+          <a:xfrm>
+            <a:off x="1508760" y="5687568"/>
+            <a:ext cx="3840480" cy="457200"/>
           </a:xfrm>
           <a:prstGeom prst="rect">
             <a:avLst/>
@@ -1204,10 +1499,13 @@
           <a:lstStyle/>
           <a:p>
             <a:pPr algn="l" indent="0" marL="0">
-              <a:buNone/>
-            </a:pPr>
-            <a:r>
-              <a:rPr lang="en-US" sz="1100" dirty="0">
+              <a:lnSpc>
+                <a:spcPct val="110000"/>
+              </a:lnSpc>
+              <a:buNone/>
+            </a:pPr>
+            <a:r>
+              <a:rPr lang="en-US" sz="1150" dirty="0">
                 <a:solidFill>
                   <a:srgbClr val="8E8E8E"/>
                 </a:solidFill>
@@ -1215,432 +1513,85 @@
                 <a:ea typeface="Calibri" pitchFamily="34" charset="-122"/>
                 <a:cs typeface="Calibri" pitchFamily="34" charset="-120"/>
               </a:rPr>
-              <a:t>Replay known care changes against Teton history.</a:t>
-            </a:r>
-            <a:endParaRPr lang="en-US" sz="1100" dirty="0"/>
-          </a:p>
-        </p:txBody>
-      </p:sp>
-      <p:sp>
-        <p:nvSpPr>
-          <p:cNvPr id="12" name="Shape 10"/>
-          <p:cNvSpPr/>
-          <p:nvPr/>
-        </p:nvSpPr>
-        <p:spPr>
-          <a:xfrm>
-            <a:off x="777240" y="2703576"/>
-            <a:ext cx="5669280" cy="774192"/>
+              <a:t>Launch candidate generation, review, and documentation.</a:t>
+            </a:r>
+            <a:endParaRPr lang="en-US" sz="1150" dirty="0"/>
+          </a:p>
+        </p:txBody>
+      </p:sp>
+      <p:sp>
+        <p:nvSpPr>
+          <p:cNvPr id="20" name="Shape 18"/>
+          <p:cNvSpPr/>
+          <p:nvPr/>
+        </p:nvSpPr>
+        <p:spPr>
+          <a:xfrm>
+            <a:off x="804672" y="5312664"/>
+            <a:ext cx="402336" cy="402336"/>
+          </a:xfrm>
+          <a:prstGeom prst="ellipse">
+            <a:avLst/>
+          </a:prstGeom>
+          <a:solidFill>
+            <a:srgbClr val="5A6CE6"/>
+          </a:solidFill>
+          <a:ln/>
+        </p:spPr>
+      </p:sp>
+      <p:sp>
+        <p:nvSpPr>
+          <p:cNvPr id="21" name="Text 19"/>
+          <p:cNvSpPr/>
+          <p:nvPr/>
+        </p:nvSpPr>
+        <p:spPr>
+          <a:xfrm>
+            <a:off x="804672" y="5312664"/>
+            <a:ext cx="402336" cy="402336"/>
+          </a:xfrm>
+          <a:prstGeom prst="rect">
+            <a:avLst/>
+          </a:prstGeom>
+          <a:noFill/>
+          <a:ln/>
+        </p:spPr>
+        <p:txBody>
+          <a:bodyPr wrap="square" lIns="0" tIns="0" rIns="0" bIns="0" rtlCol="0" anchor="ctr"/>
+          <a:lstStyle/>
+          <a:p>
+            <a:pPr algn="ctr" indent="0" marL="0">
+              <a:buNone/>
+            </a:pPr>
+            <a:r>
+              <a:rPr lang="en-US" sz="1300" b="1" dirty="0">
+                <a:solidFill>
+                  <a:srgbClr val="FFFFFF"/>
+                </a:solidFill>
+                <a:latin typeface="Calibri" pitchFamily="34" charset="0"/>
+                <a:ea typeface="Calibri" pitchFamily="34" charset="-122"/>
+                <a:cs typeface="Calibri" pitchFamily="34" charset="-120"/>
+              </a:rPr>
+              <a:t>3</a:t>
+            </a:r>
+            <a:endParaRPr lang="en-US" sz="1300" dirty="0"/>
+          </a:p>
+        </p:txBody>
+      </p:sp>
+      <p:sp>
+        <p:nvSpPr>
+          <p:cNvPr id="22" name="Shape 20"/>
+          <p:cNvSpPr/>
+          <p:nvPr/>
+        </p:nvSpPr>
+        <p:spPr>
+          <a:xfrm>
+            <a:off x="5806440" y="1920240"/>
+            <a:ext cx="5605272" cy="2057400"/>
           </a:xfrm>
           <a:prstGeom prst="roundRect">
             <a:avLst>
-              <a:gd name="adj" fmla="val 14173"/>
-            </a:avLst>
-          </a:prstGeom>
-          <a:solidFill>
-            <a:srgbClr val="F4F4F4"/>
-          </a:solidFill>
-          <a:ln w="12700">
-            <a:solidFill>
-              <a:srgbClr val="E6E6E6"/>
-            </a:solidFill>
-            <a:prstDash val="solid"/>
-          </a:ln>
-        </p:spPr>
-      </p:sp>
-      <p:sp>
-        <p:nvSpPr>
-          <p:cNvPr id="13" name="Shape 11"/>
-          <p:cNvSpPr/>
-          <p:nvPr/>
-        </p:nvSpPr>
-        <p:spPr>
-          <a:xfrm>
-            <a:off x="996696" y="2871216"/>
-            <a:ext cx="438912" cy="438912"/>
-          </a:xfrm>
-          <a:prstGeom prst="ellipse">
-            <a:avLst/>
-          </a:prstGeom>
-          <a:solidFill>
-            <a:srgbClr val="181818"/>
-          </a:solidFill>
-          <a:ln/>
-        </p:spPr>
-      </p:sp>
-      <p:sp>
-        <p:nvSpPr>
-          <p:cNvPr id="14" name="Text 12"/>
-          <p:cNvSpPr/>
-          <p:nvPr/>
-        </p:nvSpPr>
-        <p:spPr>
-          <a:xfrm>
-            <a:off x="996696" y="2871216"/>
-            <a:ext cx="438912" cy="438912"/>
-          </a:xfrm>
-          <a:prstGeom prst="rect">
-            <a:avLst/>
-          </a:prstGeom>
-          <a:noFill/>
-          <a:ln/>
-        </p:spPr>
-        <p:txBody>
-          <a:bodyPr wrap="square" lIns="0" tIns="0" rIns="0" bIns="0" rtlCol="0" anchor="ctr"/>
-          <a:lstStyle/>
-          <a:p>
-            <a:pPr algn="ctr" indent="0" marL="0">
-              <a:buNone/>
-            </a:pPr>
-            <a:r>
-              <a:rPr lang="en-US" sz="1700" b="1" dirty="0">
-                <a:solidFill>
-                  <a:srgbClr val="FFFFFF"/>
-                </a:solidFill>
-                <a:latin typeface="Calibri" pitchFamily="34" charset="0"/>
-                <a:ea typeface="Calibri" pitchFamily="34" charset="-122"/>
-                <a:cs typeface="Calibri" pitchFamily="34" charset="-120"/>
-              </a:rPr>
-              <a:t>2</a:t>
-            </a:r>
-            <a:endParaRPr lang="en-US" sz="1700" dirty="0"/>
-          </a:p>
-        </p:txBody>
-      </p:sp>
-      <p:sp>
-        <p:nvSpPr>
-          <p:cNvPr id="15" name="Text 13"/>
-          <p:cNvSpPr/>
-          <p:nvPr/>
-        </p:nvSpPr>
-        <p:spPr>
-          <a:xfrm>
-            <a:off x="1645920" y="2822448"/>
-            <a:ext cx="3840480" cy="201168"/>
-          </a:xfrm>
-          <a:prstGeom prst="rect">
-            <a:avLst/>
-          </a:prstGeom>
-          <a:noFill/>
-          <a:ln/>
-        </p:spPr>
-        <p:txBody>
-          <a:bodyPr wrap="square" lIns="0" tIns="0" rIns="0" bIns="0" rtlCol="0" anchor="t"/>
-          <a:lstStyle/>
-          <a:p>
-            <a:pPr algn="l" indent="0" marL="0">
-              <a:buNone/>
-            </a:pPr>
-            <a:r>
-              <a:rPr lang="en-US" sz="900" b="1" spc="150" kern="0" dirty="0">
-                <a:solidFill>
-                  <a:srgbClr val="8E8E8E"/>
-                </a:solidFill>
-                <a:latin typeface="Calibri" pitchFamily="34" charset="0"/>
-                <a:ea typeface="Calibri" pitchFamily="34" charset="-122"/>
-                <a:cs typeface="Calibri" pitchFamily="34" charset="-120"/>
-              </a:rPr>
-              <a:t>MONTHS 2–4</a:t>
-            </a:r>
-            <a:endParaRPr lang="en-US" sz="900" dirty="0"/>
-          </a:p>
-        </p:txBody>
-      </p:sp>
-      <p:sp>
-        <p:nvSpPr>
-          <p:cNvPr id="16" name="Text 14"/>
-          <p:cNvSpPr/>
-          <p:nvPr/>
-        </p:nvSpPr>
-        <p:spPr>
-          <a:xfrm>
-            <a:off x="1645920" y="2996184"/>
-            <a:ext cx="4023360" cy="274320"/>
-          </a:xfrm>
-          <a:prstGeom prst="rect">
-            <a:avLst/>
-          </a:prstGeom>
-          <a:noFill/>
-          <a:ln/>
-        </p:spPr>
-        <p:txBody>
-          <a:bodyPr wrap="square" lIns="0" tIns="0" rIns="0" bIns="0" rtlCol="0" anchor="t"/>
-          <a:lstStyle/>
-          <a:p>
-            <a:pPr algn="l" indent="0" marL="0">
-              <a:buNone/>
-            </a:pPr>
-            <a:r>
-              <a:rPr lang="en-US" sz="1550" b="1" dirty="0">
-                <a:solidFill>
-                  <a:srgbClr val="181818"/>
-                </a:solidFill>
-                <a:latin typeface="Calibri" pitchFamily="34" charset="0"/>
-                <a:ea typeface="Calibri" pitchFamily="34" charset="-122"/>
-                <a:cs typeface="Calibri" pitchFamily="34" charset="-120"/>
-              </a:rPr>
-              <a:t>Prove the workflow</a:t>
-            </a:r>
-            <a:endParaRPr lang="en-US" sz="1550" dirty="0"/>
-          </a:p>
-        </p:txBody>
-      </p:sp>
-      <p:sp>
-        <p:nvSpPr>
-          <p:cNvPr id="17" name="Text 15"/>
-          <p:cNvSpPr/>
-          <p:nvPr/>
-        </p:nvSpPr>
-        <p:spPr>
-          <a:xfrm>
-            <a:off x="1645920" y="3252216"/>
-            <a:ext cx="4069080" cy="219456"/>
-          </a:xfrm>
-          <a:prstGeom prst="rect">
-            <a:avLst/>
-          </a:prstGeom>
-          <a:noFill/>
-          <a:ln/>
-        </p:spPr>
-        <p:txBody>
-          <a:bodyPr wrap="square" lIns="0" tIns="0" rIns="0" bIns="0" rtlCol="0" anchor="t"/>
-          <a:lstStyle/>
-          <a:p>
-            <a:pPr algn="l" indent="0" marL="0">
-              <a:buNone/>
-            </a:pPr>
-            <a:r>
-              <a:rPr lang="en-US" sz="1100" dirty="0">
-                <a:solidFill>
-                  <a:srgbClr val="8E8E8E"/>
-                </a:solidFill>
-                <a:latin typeface="Calibri" pitchFamily="34" charset="0"/>
-                <a:ea typeface="Calibri" pitchFamily="34" charset="-122"/>
-                <a:cs typeface="Calibri" pitchFamily="34" charset="-120"/>
-              </a:rPr>
-              <a:t>Run weekly candidates by hand with 1–2 partners.</a:t>
-            </a:r>
-            <a:endParaRPr lang="en-US" sz="1100" dirty="0"/>
-          </a:p>
-        </p:txBody>
-      </p:sp>
-      <p:sp>
-        <p:nvSpPr>
-          <p:cNvPr id="18" name="Shape 16"/>
-          <p:cNvSpPr/>
-          <p:nvPr/>
-        </p:nvSpPr>
-        <p:spPr>
-          <a:xfrm>
-            <a:off x="777240" y="3596640"/>
-            <a:ext cx="5669280" cy="774192"/>
-          </a:xfrm>
-          <a:prstGeom prst="roundRect">
-            <a:avLst>
-              <a:gd name="adj" fmla="val 14173"/>
-            </a:avLst>
-          </a:prstGeom>
-          <a:solidFill>
-            <a:srgbClr val="F4F4F4"/>
-          </a:solidFill>
-          <a:ln w="12700">
-            <a:solidFill>
-              <a:srgbClr val="E6E6E6"/>
-            </a:solidFill>
-            <a:prstDash val="solid"/>
-          </a:ln>
-        </p:spPr>
-      </p:sp>
-      <p:sp>
-        <p:nvSpPr>
-          <p:cNvPr id="19" name="Shape 17"/>
-          <p:cNvSpPr/>
-          <p:nvPr/>
-        </p:nvSpPr>
-        <p:spPr>
-          <a:xfrm>
-            <a:off x="996696" y="3764280"/>
-            <a:ext cx="438912" cy="438912"/>
-          </a:xfrm>
-          <a:prstGeom prst="ellipse">
-            <a:avLst/>
-          </a:prstGeom>
-          <a:solidFill>
-            <a:srgbClr val="181818"/>
-          </a:solidFill>
-          <a:ln/>
-        </p:spPr>
-      </p:sp>
-      <p:sp>
-        <p:nvSpPr>
-          <p:cNvPr id="20" name="Text 18"/>
-          <p:cNvSpPr/>
-          <p:nvPr/>
-        </p:nvSpPr>
-        <p:spPr>
-          <a:xfrm>
-            <a:off x="996696" y="3764280"/>
-            <a:ext cx="438912" cy="438912"/>
-          </a:xfrm>
-          <a:prstGeom prst="rect">
-            <a:avLst/>
-          </a:prstGeom>
-          <a:noFill/>
-          <a:ln/>
-        </p:spPr>
-        <p:txBody>
-          <a:bodyPr wrap="square" lIns="0" tIns="0" rIns="0" bIns="0" rtlCol="0" anchor="ctr"/>
-          <a:lstStyle/>
-          <a:p>
-            <a:pPr algn="ctr" indent="0" marL="0">
-              <a:buNone/>
-            </a:pPr>
-            <a:r>
-              <a:rPr lang="en-US" sz="1700" b="1" dirty="0">
-                <a:solidFill>
-                  <a:srgbClr val="FFFFFF"/>
-                </a:solidFill>
-                <a:latin typeface="Calibri" pitchFamily="34" charset="0"/>
-                <a:ea typeface="Calibri" pitchFamily="34" charset="-122"/>
-                <a:cs typeface="Calibri" pitchFamily="34" charset="-120"/>
-              </a:rPr>
-              <a:t>3</a:t>
-            </a:r>
-            <a:endParaRPr lang="en-US" sz="1700" dirty="0"/>
-          </a:p>
-        </p:txBody>
-      </p:sp>
-      <p:sp>
-        <p:nvSpPr>
-          <p:cNvPr id="21" name="Text 19"/>
-          <p:cNvSpPr/>
-          <p:nvPr/>
-        </p:nvSpPr>
-        <p:spPr>
-          <a:xfrm>
-            <a:off x="1645920" y="3715512"/>
-            <a:ext cx="3840480" cy="201168"/>
-          </a:xfrm>
-          <a:prstGeom prst="rect">
-            <a:avLst/>
-          </a:prstGeom>
-          <a:noFill/>
-          <a:ln/>
-        </p:spPr>
-        <p:txBody>
-          <a:bodyPr wrap="square" lIns="0" tIns="0" rIns="0" bIns="0" rtlCol="0" anchor="t"/>
-          <a:lstStyle/>
-          <a:p>
-            <a:pPr algn="l" indent="0" marL="0">
-              <a:buNone/>
-            </a:pPr>
-            <a:r>
-              <a:rPr lang="en-US" sz="900" b="1" spc="150" kern="0" dirty="0">
-                <a:solidFill>
-                  <a:srgbClr val="8E8E8E"/>
-                </a:solidFill>
-                <a:latin typeface="Calibri" pitchFamily="34" charset="0"/>
-                <a:ea typeface="Calibri" pitchFamily="34" charset="-122"/>
-                <a:cs typeface="Calibri" pitchFamily="34" charset="-120"/>
-              </a:rPr>
-              <a:t>MONTHS 4–6</a:t>
-            </a:r>
-            <a:endParaRPr lang="en-US" sz="900" dirty="0"/>
-          </a:p>
-        </p:txBody>
-      </p:sp>
-      <p:sp>
-        <p:nvSpPr>
-          <p:cNvPr id="22" name="Text 20"/>
-          <p:cNvSpPr/>
-          <p:nvPr/>
-        </p:nvSpPr>
-        <p:spPr>
-          <a:xfrm>
-            <a:off x="1645920" y="3889248"/>
-            <a:ext cx="4023360" cy="274320"/>
-          </a:xfrm>
-          <a:prstGeom prst="rect">
-            <a:avLst/>
-          </a:prstGeom>
-          <a:noFill/>
-          <a:ln/>
-        </p:spPr>
-        <p:txBody>
-          <a:bodyPr wrap="square" lIns="0" tIns="0" rIns="0" bIns="0" rtlCol="0" anchor="t"/>
-          <a:lstStyle/>
-          <a:p>
-            <a:pPr algn="l" indent="0" marL="0">
-              <a:buNone/>
-            </a:pPr>
-            <a:r>
-              <a:rPr lang="en-US" sz="1550" b="1" dirty="0">
-                <a:solidFill>
-                  <a:srgbClr val="181818"/>
-                </a:solidFill>
-                <a:latin typeface="Calibri" pitchFamily="34" charset="0"/>
-                <a:ea typeface="Calibri" pitchFamily="34" charset="-122"/>
-                <a:cs typeface="Calibri" pitchFamily="34" charset="-120"/>
-              </a:rPr>
-              <a:t>Automate the loop</a:t>
-            </a:r>
-            <a:endParaRPr lang="en-US" sz="1550" dirty="0"/>
-          </a:p>
-        </p:txBody>
-      </p:sp>
-      <p:sp>
-        <p:nvSpPr>
-          <p:cNvPr id="23" name="Text 21"/>
-          <p:cNvSpPr/>
-          <p:nvPr/>
-        </p:nvSpPr>
-        <p:spPr>
-          <a:xfrm>
-            <a:off x="1645920" y="4145280"/>
-            <a:ext cx="4069080" cy="219456"/>
-          </a:xfrm>
-          <a:prstGeom prst="rect">
-            <a:avLst/>
-          </a:prstGeom>
-          <a:noFill/>
-          <a:ln/>
-        </p:spPr>
-        <p:txBody>
-          <a:bodyPr wrap="square" lIns="0" tIns="0" rIns="0" bIns="0" rtlCol="0" anchor="t"/>
-          <a:lstStyle/>
-          <a:p>
-            <a:pPr algn="l" indent="0" marL="0">
-              <a:buNone/>
-            </a:pPr>
-            <a:r>
-              <a:rPr lang="en-US" sz="1100" dirty="0">
-                <a:solidFill>
-                  <a:srgbClr val="8E8E8E"/>
-                </a:solidFill>
-                <a:latin typeface="Calibri" pitchFamily="34" charset="0"/>
-                <a:ea typeface="Calibri" pitchFamily="34" charset="-122"/>
-                <a:cs typeface="Calibri" pitchFamily="34" charset="-120"/>
-              </a:rPr>
-              <a:t>Launch generation, review, and documentation.</a:t>
-            </a:r>
-            <a:endParaRPr lang="en-US" sz="1100" dirty="0"/>
-          </a:p>
-        </p:txBody>
-      </p:sp>
-      <p:sp>
-        <p:nvSpPr>
-          <p:cNvPr id="24" name="Shape 22"/>
-          <p:cNvSpPr/>
-          <p:nvPr/>
-        </p:nvSpPr>
-        <p:spPr>
-          <a:xfrm>
-            <a:off x="6702552" y="1810512"/>
-            <a:ext cx="4709160" cy="2560320"/>
-          </a:xfrm>
-          <a:prstGeom prst="roundRect">
-            <a:avLst>
-              <a:gd name="adj" fmla="val 5000"/>
+              <a:gd name="adj" fmla="val 6222"/>
             </a:avLst>
           </a:prstGeom>
           <a:solidFill>
@@ -1658,13 +1609,13 @@
       </p:sp>
       <p:sp>
         <p:nvSpPr>
-          <p:cNvPr id="25" name="Shape 23"/>
-          <p:cNvSpPr/>
-          <p:nvPr/>
-        </p:nvSpPr>
-        <p:spPr>
-          <a:xfrm>
-            <a:off x="7086600" y="2148840"/>
+          <p:cNvPr id="23" name="Shape 21"/>
+          <p:cNvSpPr/>
+          <p:nvPr/>
+        </p:nvSpPr>
+        <p:spPr>
+          <a:xfrm>
+            <a:off x="6190488" y="2221992"/>
             <a:ext cx="109728" cy="109728"/>
           </a:xfrm>
           <a:prstGeom prst="ellipse">
@@ -1678,13 +1629,192 @@
       </p:sp>
       <p:sp>
         <p:nvSpPr>
+          <p:cNvPr id="24" name="Text 22"/>
+          <p:cNvSpPr/>
+          <p:nvPr/>
+        </p:nvSpPr>
+        <p:spPr>
+          <a:xfrm>
+            <a:off x="6391656" y="2130552"/>
+            <a:ext cx="7315200" cy="292608"/>
+          </a:xfrm>
+          <a:prstGeom prst="rect">
+            <a:avLst/>
+          </a:prstGeom>
+          <a:noFill/>
+          <a:ln/>
+        </p:spPr>
+        <p:txBody>
+          <a:bodyPr wrap="square" lIns="0" tIns="0" rIns="0" bIns="0" rtlCol="0" anchor="ctr"/>
+          <a:lstStyle/>
+          <a:p>
+            <a:pPr algn="l" indent="0" marL="0">
+              <a:buNone/>
+            </a:pPr>
+            <a:r>
+              <a:rPr lang="en-US" sz="1100" b="1" spc="200" kern="0" dirty="0">
+                <a:solidFill>
+                  <a:srgbClr val="A8ABB5"/>
+                </a:solidFill>
+                <a:latin typeface="Calibri" pitchFamily="34" charset="0"/>
+                <a:ea typeface="Calibri" pitchFamily="34" charset="-122"/>
+                <a:cs typeface="Calibri" pitchFamily="34" charset="-120"/>
+              </a:rPr>
+              <a:t>NORTH STAR</a:t>
+            </a:r>
+            <a:endParaRPr lang="en-US" sz="1100" dirty="0"/>
+          </a:p>
+        </p:txBody>
+      </p:sp>
+      <p:sp>
+        <p:nvSpPr>
+          <p:cNvPr id="25" name="Text 23"/>
+          <p:cNvSpPr/>
+          <p:nvPr/>
+        </p:nvSpPr>
+        <p:spPr>
+          <a:xfrm>
+            <a:off x="6190488" y="2542032"/>
+            <a:ext cx="4837176" cy="310896"/>
+          </a:xfrm>
+          <a:prstGeom prst="rect">
+            <a:avLst/>
+          </a:prstGeom>
+          <a:noFill/>
+          <a:ln/>
+        </p:spPr>
+        <p:txBody>
+          <a:bodyPr wrap="square" lIns="0" tIns="0" rIns="0" bIns="0" rtlCol="0" anchor="t"/>
+          <a:lstStyle/>
+          <a:p>
+            <a:pPr algn="l" indent="0" marL="0">
+              <a:lnSpc>
+                <a:spcPct val="104000"/>
+              </a:lnSpc>
+              <a:buNone/>
+            </a:pPr>
+            <a:r>
+              <a:rPr lang="en-US" sz="1600" dirty="0">
+                <a:solidFill>
+                  <a:srgbClr val="FFFFFF"/>
+                </a:solidFill>
+                <a:latin typeface="Calibri" pitchFamily="34" charset="0"/>
+                <a:ea typeface="Calibri" pitchFamily="34" charset="-122"/>
+                <a:cs typeface="Calibri" pitchFamily="34" charset="-120"/>
+              </a:rPr>
+              <a:t>How early we catch meaningful decline</a:t>
+            </a:r>
+            <a:endParaRPr lang="en-US" sz="1600" dirty="0"/>
+          </a:p>
+        </p:txBody>
+      </p:sp>
+      <p:sp>
+        <p:nvSpPr>
           <p:cNvPr id="26" name="Text 24"/>
           <p:cNvSpPr/>
           <p:nvPr/>
         </p:nvSpPr>
         <p:spPr>
           <a:xfrm>
-            <a:off x="7287768" y="2057400"/>
+            <a:off x="6190488" y="2926080"/>
+            <a:ext cx="4837176" cy="566928"/>
+          </a:xfrm>
+          <a:prstGeom prst="rect">
+            <a:avLst/>
+          </a:prstGeom>
+          <a:noFill/>
+          <a:ln/>
+        </p:spPr>
+        <p:txBody>
+          <a:bodyPr wrap="square" lIns="0" tIns="0" rIns="0" bIns="0" rtlCol="0" anchor="t"/>
+          <a:lstStyle/>
+          <a:p>
+            <a:pPr algn="l" indent="0" marL="0">
+              <a:buNone/>
+            </a:pPr>
+            <a:r>
+              <a:rPr lang="en-US" sz="3400" b="1" dirty="0">
+                <a:solidFill>
+                  <a:srgbClr val="5A6CE6"/>
+                </a:solidFill>
+                <a:latin typeface="Calibri" pitchFamily="34" charset="0"/>
+                <a:ea typeface="Calibri" pitchFamily="34" charset="-122"/>
+                <a:cs typeface="Calibri" pitchFamily="34" charset="-120"/>
+              </a:rPr>
+              <a:t>Week 2,</a:t>
+            </a:r>
+            <a:endParaRPr lang="en-US" sz="3400" dirty="0"/>
+          </a:p>
+        </p:txBody>
+      </p:sp>
+      <p:sp>
+        <p:nvSpPr>
+          <p:cNvPr id="27" name="Text 25"/>
+          <p:cNvSpPr/>
+          <p:nvPr/>
+        </p:nvSpPr>
+        <p:spPr>
+          <a:xfrm>
+            <a:off x="6190488" y="3511296"/>
+            <a:ext cx="4837176" cy="457200"/>
+          </a:xfrm>
+          <a:prstGeom prst="rect">
+            <a:avLst/>
+          </a:prstGeom>
+          <a:noFill/>
+          <a:ln/>
+        </p:spPr>
+        <p:txBody>
+          <a:bodyPr wrap="square" lIns="0" tIns="0" rIns="0" bIns="0" rtlCol="0" anchor="t"/>
+          <a:lstStyle/>
+          <a:p>
+            <a:pPr algn="l" indent="0" marL="0">
+              <a:buNone/>
+            </a:pPr>
+            <a:r>
+              <a:rPr lang="en-US" sz="2400" b="1" dirty="0">
+                <a:solidFill>
+                  <a:srgbClr val="A8ABB5"/>
+                </a:solidFill>
+                <a:latin typeface="Calibri" pitchFamily="34" charset="0"/>
+                <a:ea typeface="Calibri" pitchFamily="34" charset="-122"/>
+                <a:cs typeface="Calibri" pitchFamily="34" charset="-120"/>
+              </a:rPr>
+              <a:t>not Week 12.</a:t>
+            </a:r>
+            <a:endParaRPr lang="en-US" sz="2400" dirty="0"/>
+          </a:p>
+        </p:txBody>
+      </p:sp>
+      <p:sp>
+        <p:nvSpPr>
+          <p:cNvPr id="28" name="Shape 26"/>
+          <p:cNvSpPr/>
+          <p:nvPr/>
+        </p:nvSpPr>
+        <p:spPr>
+          <a:xfrm>
+            <a:off x="5806440" y="4151376"/>
+            <a:ext cx="109728" cy="109728"/>
+          </a:xfrm>
+          <a:prstGeom prst="ellipse">
+            <a:avLst/>
+          </a:prstGeom>
+          <a:solidFill>
+            <a:srgbClr val="5A6CE6"/>
+          </a:solidFill>
+          <a:ln/>
+        </p:spPr>
+      </p:sp>
+      <p:sp>
+        <p:nvSpPr>
+          <p:cNvPr id="29" name="Text 27"/>
+          <p:cNvSpPr/>
+          <p:nvPr/>
+        </p:nvSpPr>
+        <p:spPr>
+          <a:xfrm>
+            <a:off x="6007608" y="4059936"/>
             <a:ext cx="7315200" cy="292608"/>
           </a:xfrm>
           <a:prstGeom prst="rect">
@@ -1703,13 +1833,13 @@
             <a:r>
               <a:rPr lang="en-US" sz="1100" b="1" spc="200" kern="0" dirty="0">
                 <a:solidFill>
-                  <a:srgbClr val="A8ABB5"/>
-                </a:solidFill>
-                <a:latin typeface="Calibri" pitchFamily="34" charset="0"/>
-                <a:ea typeface="Calibri" pitchFamily="34" charset="-122"/>
-                <a:cs typeface="Calibri" pitchFamily="34" charset="-120"/>
-              </a:rPr>
-              <a:t>NORTH STAR</a:t>
+                  <a:srgbClr val="8E8E8E"/>
+                </a:solidFill>
+                <a:latin typeface="Calibri" pitchFamily="34" charset="0"/>
+                <a:ea typeface="Calibri" pitchFamily="34" charset="-122"/>
+                <a:cs typeface="Calibri" pitchFamily="34" charset="-120"/>
+              </a:rPr>
+              <a:t>IN THE OPERATIONAL CYCLE</a:t>
             </a:r>
             <a:endParaRPr lang="en-US" sz="1100" dirty="0"/>
           </a:p>
@@ -1717,14 +1847,14 @@
       </p:sp>
       <p:sp>
         <p:nvSpPr>
-          <p:cNvPr id="27" name="Text 25"/>
-          <p:cNvSpPr/>
-          <p:nvPr/>
-        </p:nvSpPr>
-        <p:spPr>
-          <a:xfrm>
-            <a:off x="7086600" y="2468880"/>
-            <a:ext cx="3941064" cy="822960"/>
+          <p:cNvPr id="30" name="Text 28"/>
+          <p:cNvSpPr/>
+          <p:nvPr/>
+        </p:nvSpPr>
+        <p:spPr>
+          <a:xfrm>
+            <a:off x="5806440" y="4453128"/>
+            <a:ext cx="1691640" cy="256032"/>
           </a:xfrm>
           <a:prstGeom prst="rect">
             <a:avLst/>
@@ -1737,21 +1867,96 @@
           <a:lstStyle/>
           <a:p>
             <a:pPr algn="l" indent="0" marL="0">
-              <a:lnSpc>
-                <a:spcPct val="108000"/>
-              </a:lnSpc>
+              <a:buNone/>
+            </a:pPr>
+            <a:r>
+              <a:rPr lang="en-US" sz="1350" b="1" dirty="0">
+                <a:solidFill>
+                  <a:srgbClr val="181818"/>
+                </a:solidFill>
+                <a:latin typeface="Calibri" pitchFamily="34" charset="0"/>
+                <a:ea typeface="Calibri" pitchFamily="34" charset="-122"/>
+                <a:cs typeface="Calibri" pitchFamily="34" charset="-120"/>
+              </a:rPr>
+              <a:t>Reviewed</a:t>
+            </a:r>
+            <a:endParaRPr lang="en-US" sz="1350" dirty="0"/>
+          </a:p>
+        </p:txBody>
+      </p:sp>
+      <p:sp>
+        <p:nvSpPr>
+          <p:cNvPr id="31" name="Text 29"/>
+          <p:cNvSpPr/>
+          <p:nvPr/>
+        </p:nvSpPr>
+        <p:spPr>
+          <a:xfrm>
+            <a:off x="5806440" y="4690872"/>
+            <a:ext cx="1737360" cy="201168"/>
+          </a:xfrm>
+          <a:prstGeom prst="rect">
+            <a:avLst/>
+          </a:prstGeom>
+          <a:noFill/>
+          <a:ln/>
+        </p:spPr>
+        <p:txBody>
+          <a:bodyPr wrap="square" lIns="0" tIns="0" rIns="0" bIns="0" rtlCol="0" anchor="t"/>
+          <a:lstStyle/>
+          <a:p>
+            <a:pPr algn="l" indent="0" marL="0">
+              <a:buNone/>
+            </a:pPr>
+            <a:r>
+              <a:rPr lang="en-US" sz="950" dirty="0">
+                <a:solidFill>
+                  <a:srgbClr val="8E8E8E"/>
+                </a:solidFill>
+                <a:latin typeface="Calibri" pitchFamily="34" charset="0"/>
+                <a:ea typeface="Calibri" pitchFamily="34" charset="-122"/>
+                <a:cs typeface="Calibri" pitchFamily="34" charset="-120"/>
+              </a:rPr>
+              <a:t>resolved in cadence</a:t>
+            </a:r>
+            <a:endParaRPr lang="en-US" sz="950" dirty="0"/>
+          </a:p>
+        </p:txBody>
+      </p:sp>
+      <p:sp>
+        <p:nvSpPr>
+          <p:cNvPr id="32" name="Text 30"/>
+          <p:cNvSpPr/>
+          <p:nvPr/>
+        </p:nvSpPr>
+        <p:spPr>
+          <a:xfrm>
+            <a:off x="7406640" y="4453128"/>
+            <a:ext cx="320040" cy="256032"/>
+          </a:xfrm>
+          <a:prstGeom prst="rect">
+            <a:avLst/>
+          </a:prstGeom>
+          <a:noFill/>
+          <a:ln/>
+        </p:spPr>
+        <p:txBody>
+          <a:bodyPr wrap="square" lIns="0" tIns="0" rIns="0" bIns="0" rtlCol="0" anchor="ctr"/>
+          <a:lstStyle/>
+          <a:p>
+            <a:pPr algn="ctr" indent="0" marL="0">
               <a:buNone/>
             </a:pPr>
             <a:r>
               <a:rPr lang="en-US" sz="1500" dirty="0">
                 <a:solidFill>
-                  <a:srgbClr val="FFFFFF"/>
-                </a:solidFill>
-                <a:latin typeface="Calibri" pitchFamily="34" charset="0"/>
-                <a:ea typeface="Calibri" pitchFamily="34" charset="-122"/>
-                <a:cs typeface="Calibri" pitchFamily="34" charset="-120"/>
-              </a:rPr>
-              <a:t>Median weeks earlier that meaningful decline is reviewed</a:t>
+                  <a:srgbClr val="AFAFB6"/>
+                </a:solidFill>
+                <a:latin typeface="Calibri" pitchFamily="34" charset="0"/>
+                <a:ea typeface="Calibri" pitchFamily="34" charset="-122"/>
+                <a:cs typeface="Calibri" pitchFamily="34" charset="-120"/>
+              </a:rPr>
+              <a:t>→</a:t>
             </a:r>
             <a:endParaRPr lang="en-US" sz="1500" dirty="0"/>
           </a:p>
@@ -1759,14 +1964,14 @@
       </p:sp>
       <p:sp>
         <p:nvSpPr>
-          <p:cNvPr id="28" name="Text 26"/>
-          <p:cNvSpPr/>
-          <p:nvPr/>
-        </p:nvSpPr>
-        <p:spPr>
-          <a:xfrm>
-            <a:off x="7086600" y="3291840"/>
-            <a:ext cx="3941064" cy="566928"/>
+          <p:cNvPr id="33" name="Text 31"/>
+          <p:cNvSpPr/>
+          <p:nvPr/>
+        </p:nvSpPr>
+        <p:spPr>
+          <a:xfrm>
+            <a:off x="7726680" y="4453128"/>
+            <a:ext cx="1691640" cy="256032"/>
           </a:xfrm>
           <a:prstGeom prst="rect">
             <a:avLst/>
@@ -1782,7 +1987,124 @@
               <a:buNone/>
             </a:pPr>
             <a:r>
-              <a:rPr lang="en-US" sz="3800" b="1" dirty="0">
+              <a:rPr lang="en-US" sz="1350" b="1" dirty="0">
+                <a:solidFill>
+                  <a:srgbClr val="181818"/>
+                </a:solidFill>
+                <a:latin typeface="Calibri" pitchFamily="34" charset="0"/>
+                <a:ea typeface="Calibri" pitchFamily="34" charset="-122"/>
+                <a:cs typeface="Calibri" pitchFamily="34" charset="-120"/>
+              </a:rPr>
+              <a:t>Acted on</a:t>
+            </a:r>
+            <a:endParaRPr lang="en-US" sz="1350" dirty="0"/>
+          </a:p>
+        </p:txBody>
+      </p:sp>
+      <p:sp>
+        <p:nvSpPr>
+          <p:cNvPr id="34" name="Text 32"/>
+          <p:cNvSpPr/>
+          <p:nvPr/>
+        </p:nvSpPr>
+        <p:spPr>
+          <a:xfrm>
+            <a:off x="7726680" y="4690872"/>
+            <a:ext cx="1737360" cy="201168"/>
+          </a:xfrm>
+          <a:prstGeom prst="rect">
+            <a:avLst/>
+          </a:prstGeom>
+          <a:noFill/>
+          <a:ln/>
+        </p:spPr>
+        <p:txBody>
+          <a:bodyPr wrap="square" lIns="0" tIns="0" rIns="0" bIns="0" rtlCol="0" anchor="t"/>
+          <a:lstStyle/>
+          <a:p>
+            <a:pPr algn="l" indent="0" marL="0">
+              <a:buNone/>
+            </a:pPr>
+            <a:r>
+              <a:rPr lang="en-US" sz="950" dirty="0">
+                <a:solidFill>
+                  <a:srgbClr val="8E8E8E"/>
+                </a:solidFill>
+                <a:latin typeface="Calibri" pitchFamily="34" charset="0"/>
+                <a:ea typeface="Calibri" pitchFamily="34" charset="-122"/>
+                <a:cs typeface="Calibri" pitchFamily="34" charset="-120"/>
+              </a:rPr>
+              <a:t>intervention started</a:t>
+            </a:r>
+            <a:endParaRPr lang="en-US" sz="950" dirty="0"/>
+          </a:p>
+        </p:txBody>
+      </p:sp>
+      <p:sp>
+        <p:nvSpPr>
+          <p:cNvPr id="35" name="Text 33"/>
+          <p:cNvSpPr/>
+          <p:nvPr/>
+        </p:nvSpPr>
+        <p:spPr>
+          <a:xfrm>
+            <a:off x="9326880" y="4453128"/>
+            <a:ext cx="320040" cy="256032"/>
+          </a:xfrm>
+          <a:prstGeom prst="rect">
+            <a:avLst/>
+          </a:prstGeom>
+          <a:noFill/>
+          <a:ln/>
+        </p:spPr>
+        <p:txBody>
+          <a:bodyPr wrap="square" lIns="0" tIns="0" rIns="0" bIns="0" rtlCol="0" anchor="ctr"/>
+          <a:lstStyle/>
+          <a:p>
+            <a:pPr algn="ctr" indent="0" marL="0">
+              <a:buNone/>
+            </a:pPr>
+            <a:r>
+              <a:rPr lang="en-US" sz="1500" dirty="0">
+                <a:solidFill>
+                  <a:srgbClr val="AFAFB6"/>
+                </a:solidFill>
+                <a:latin typeface="Calibri" pitchFamily="34" charset="0"/>
+                <a:ea typeface="Calibri" pitchFamily="34" charset="-122"/>
+                <a:cs typeface="Calibri" pitchFamily="34" charset="-120"/>
+              </a:rPr>
+              <a:t>→</a:t>
+            </a:r>
+            <a:endParaRPr lang="en-US" sz="1500" dirty="0"/>
+          </a:p>
+        </p:txBody>
+      </p:sp>
+      <p:sp>
+        <p:nvSpPr>
+          <p:cNvPr id="36" name="Text 34"/>
+          <p:cNvSpPr/>
+          <p:nvPr/>
+        </p:nvSpPr>
+        <p:spPr>
+          <a:xfrm>
+            <a:off x="9646920" y="4453128"/>
+            <a:ext cx="1691640" cy="256032"/>
+          </a:xfrm>
+          <a:prstGeom prst="rect">
+            <a:avLst/>
+          </a:prstGeom>
+          <a:noFill/>
+          <a:ln/>
+        </p:spPr>
+        <p:txBody>
+          <a:bodyPr wrap="square" lIns="0" tIns="0" rIns="0" bIns="0" rtlCol="0" anchor="t"/>
+          <a:lstStyle/>
+          <a:p>
+            <a:pPr algn="l" indent="0" marL="0">
+              <a:buNone/>
+            </a:pPr>
+            <a:r>
+              <a:rPr lang="en-US" sz="1350" b="1" dirty="0">
                 <a:solidFill>
                   <a:srgbClr val="5A6CE6"/>
                 </a:solidFill>
@@ -1790,22 +2112,22 @@
                 <a:ea typeface="Calibri" pitchFamily="34" charset="-122"/>
                 <a:cs typeface="Calibri" pitchFamily="34" charset="-120"/>
               </a:rPr>
-              <a:t>Week 2,</a:t>
-            </a:r>
-            <a:endParaRPr lang="en-US" sz="3800" dirty="0"/>
-          </a:p>
-        </p:txBody>
-      </p:sp>
-      <p:sp>
-        <p:nvSpPr>
-          <p:cNvPr id="29" name="Text 27"/>
-          <p:cNvSpPr/>
-          <p:nvPr/>
-        </p:nvSpPr>
-        <p:spPr>
-          <a:xfrm>
-            <a:off x="7086600" y="3840480"/>
-            <a:ext cx="3941064" cy="457200"/>
+              <a:t>Earlier</a:t>
+            </a:r>
+            <a:endParaRPr lang="en-US" sz="1350" dirty="0"/>
+          </a:p>
+        </p:txBody>
+      </p:sp>
+      <p:sp>
+        <p:nvSpPr>
+          <p:cNvPr id="37" name="Text 35"/>
+          <p:cNvSpPr/>
+          <p:nvPr/>
+        </p:nvSpPr>
+        <p:spPr>
+          <a:xfrm>
+            <a:off x="9646920" y="4690872"/>
+            <a:ext cx="1737360" cy="201168"/>
           </a:xfrm>
           <a:prstGeom prst="rect">
             <a:avLst/>
@@ -1821,358 +2143,34 @@
               <a:buNone/>
             </a:pPr>
             <a:r>
-              <a:rPr lang="en-US" sz="2700" b="1" dirty="0">
-                <a:solidFill>
-                  <a:srgbClr val="A8ABB5"/>
-                </a:solidFill>
-                <a:latin typeface="Calibri" pitchFamily="34" charset="0"/>
-                <a:ea typeface="Calibri" pitchFamily="34" charset="-122"/>
-                <a:cs typeface="Calibri" pitchFamily="34" charset="-120"/>
-              </a:rPr>
-              <a:t>not Week 12.</a:t>
-            </a:r>
-            <a:endParaRPr lang="en-US" sz="2700" dirty="0"/>
-          </a:p>
-        </p:txBody>
-      </p:sp>
-      <p:sp>
-        <p:nvSpPr>
-          <p:cNvPr id="30" name="Shape 28"/>
-          <p:cNvSpPr/>
-          <p:nvPr/>
-        </p:nvSpPr>
-        <p:spPr>
-          <a:xfrm>
-            <a:off x="777240" y="4535424"/>
-            <a:ext cx="1792224" cy="1572768"/>
+              <a:rPr lang="en-US" sz="950" dirty="0">
+                <a:solidFill>
+                  <a:srgbClr val="8E8E8E"/>
+                </a:solidFill>
+                <a:latin typeface="Calibri" pitchFamily="34" charset="0"/>
+                <a:ea typeface="Calibri" pitchFamily="34" charset="-122"/>
+                <a:cs typeface="Calibri" pitchFamily="34" charset="-120"/>
+              </a:rPr>
+              <a:t>with fewer delays</a:t>
+            </a:r>
+            <a:endParaRPr lang="en-US" sz="950" dirty="0"/>
+          </a:p>
+        </p:txBody>
+      </p:sp>
+      <p:sp>
+        <p:nvSpPr>
+          <p:cNvPr id="38" name="Shape 36"/>
+          <p:cNvSpPr/>
+          <p:nvPr/>
+        </p:nvSpPr>
+        <p:spPr>
+          <a:xfrm>
+            <a:off x="5806440" y="5120640"/>
+            <a:ext cx="5605272" cy="932688"/>
           </a:xfrm>
           <a:prstGeom prst="roundRect">
             <a:avLst>
-              <a:gd name="adj" fmla="val 6977"/>
-            </a:avLst>
-          </a:prstGeom>
-          <a:solidFill>
-            <a:srgbClr val="F4F4F4"/>
-          </a:solidFill>
-          <a:ln w="12700">
-            <a:solidFill>
-              <a:srgbClr val="E6E6E6"/>
-            </a:solidFill>
-            <a:prstDash val="solid"/>
-          </a:ln>
-        </p:spPr>
-      </p:sp>
-      <p:sp>
-        <p:nvSpPr>
-          <p:cNvPr id="31" name="Text 29"/>
-          <p:cNvSpPr/>
-          <p:nvPr/>
-        </p:nvSpPr>
-        <p:spPr>
-          <a:xfrm>
-            <a:off x="996696" y="4791456"/>
-            <a:ext cx="1389888" cy="274320"/>
-          </a:xfrm>
-          <a:prstGeom prst="rect">
-            <a:avLst/>
-          </a:prstGeom>
-          <a:noFill/>
-          <a:ln/>
-        </p:spPr>
-        <p:txBody>
-          <a:bodyPr wrap="square" lIns="0" tIns="0" rIns="0" bIns="0" rtlCol="0" anchor="t"/>
-          <a:lstStyle/>
-          <a:p>
-            <a:pPr algn="l" indent="0" marL="0">
-              <a:buNone/>
-            </a:pPr>
-            <a:r>
-              <a:rPr lang="en-US" sz="1450" b="1" dirty="0">
-                <a:solidFill>
-                  <a:srgbClr val="181818"/>
-                </a:solidFill>
-                <a:latin typeface="Calibri" pitchFamily="34" charset="0"/>
-                <a:ea typeface="Calibri" pitchFamily="34" charset="-122"/>
-                <a:cs typeface="Calibri" pitchFamily="34" charset="-120"/>
-              </a:rPr>
-              <a:t>Reviewed</a:t>
-            </a:r>
-            <a:endParaRPr lang="en-US" sz="1450" dirty="0"/>
-          </a:p>
-        </p:txBody>
-      </p:sp>
-      <p:sp>
-        <p:nvSpPr>
-          <p:cNvPr id="32" name="Text 30"/>
-          <p:cNvSpPr/>
-          <p:nvPr/>
-        </p:nvSpPr>
-        <p:spPr>
-          <a:xfrm>
-            <a:off x="996696" y="5138928"/>
-            <a:ext cx="1389888" cy="822960"/>
-          </a:xfrm>
-          <a:prstGeom prst="rect">
-            <a:avLst/>
-          </a:prstGeom>
-          <a:noFill/>
-          <a:ln/>
-        </p:spPr>
-        <p:txBody>
-          <a:bodyPr wrap="square" lIns="0" tIns="0" rIns="0" bIns="0" rtlCol="0" anchor="t"/>
-          <a:lstStyle/>
-          <a:p>
-            <a:pPr algn="l" indent="0" marL="0">
-              <a:lnSpc>
-                <a:spcPct val="110000"/>
-              </a:lnSpc>
-              <a:buNone/>
-            </a:pPr>
-            <a:r>
-              <a:rPr lang="en-US" sz="1050" dirty="0">
-                <a:solidFill>
-                  <a:srgbClr val="8E8E8E"/>
-                </a:solidFill>
-                <a:latin typeface="Calibri" pitchFamily="34" charset="0"/>
-                <a:ea typeface="Calibri" pitchFamily="34" charset="-122"/>
-                <a:cs typeface="Calibri" pitchFamily="34" charset="-120"/>
-              </a:rPr>
-              <a:t>Resolved in cadence and confirmed meaningful.</a:t>
-            </a:r>
-            <a:endParaRPr lang="en-US" sz="1050" dirty="0"/>
-          </a:p>
-        </p:txBody>
-      </p:sp>
-      <p:sp>
-        <p:nvSpPr>
-          <p:cNvPr id="33" name="Shape 31"/>
-          <p:cNvSpPr/>
-          <p:nvPr/>
-        </p:nvSpPr>
-        <p:spPr>
-          <a:xfrm>
-            <a:off x="2715768" y="4535424"/>
-            <a:ext cx="1792224" cy="1572768"/>
-          </a:xfrm>
-          <a:prstGeom prst="roundRect">
-            <a:avLst>
-              <a:gd name="adj" fmla="val 6977"/>
-            </a:avLst>
-          </a:prstGeom>
-          <a:solidFill>
-            <a:srgbClr val="F4F4F4"/>
-          </a:solidFill>
-          <a:ln w="12700">
-            <a:solidFill>
-              <a:srgbClr val="E6E6E6"/>
-            </a:solidFill>
-            <a:prstDash val="solid"/>
-          </a:ln>
-        </p:spPr>
-      </p:sp>
-      <p:sp>
-        <p:nvSpPr>
-          <p:cNvPr id="34" name="Text 32"/>
-          <p:cNvSpPr/>
-          <p:nvPr/>
-        </p:nvSpPr>
-        <p:spPr>
-          <a:xfrm>
-            <a:off x="2935224" y="4791456"/>
-            <a:ext cx="1389888" cy="274320"/>
-          </a:xfrm>
-          <a:prstGeom prst="rect">
-            <a:avLst/>
-          </a:prstGeom>
-          <a:noFill/>
-          <a:ln/>
-        </p:spPr>
-        <p:txBody>
-          <a:bodyPr wrap="square" lIns="0" tIns="0" rIns="0" bIns="0" rtlCol="0" anchor="t"/>
-          <a:lstStyle/>
-          <a:p>
-            <a:pPr algn="l" indent="0" marL="0">
-              <a:buNone/>
-            </a:pPr>
-            <a:r>
-              <a:rPr lang="en-US" sz="1450" b="1" dirty="0">
-                <a:solidFill>
-                  <a:srgbClr val="181818"/>
-                </a:solidFill>
-                <a:latin typeface="Calibri" pitchFamily="34" charset="0"/>
-                <a:ea typeface="Calibri" pitchFamily="34" charset="-122"/>
-                <a:cs typeface="Calibri" pitchFamily="34" charset="-120"/>
-              </a:rPr>
-              <a:t>Acted on</a:t>
-            </a:r>
-            <a:endParaRPr lang="en-US" sz="1450" dirty="0"/>
-          </a:p>
-        </p:txBody>
-      </p:sp>
-      <p:sp>
-        <p:nvSpPr>
-          <p:cNvPr id="35" name="Text 33"/>
-          <p:cNvSpPr/>
-          <p:nvPr/>
-        </p:nvSpPr>
-        <p:spPr>
-          <a:xfrm>
-            <a:off x="2935224" y="5138928"/>
-            <a:ext cx="1389888" cy="822960"/>
-          </a:xfrm>
-          <a:prstGeom prst="rect">
-            <a:avLst/>
-          </a:prstGeom>
-          <a:noFill/>
-          <a:ln/>
-        </p:spPr>
-        <p:txBody>
-          <a:bodyPr wrap="square" lIns="0" tIns="0" rIns="0" bIns="0" rtlCol="0" anchor="t"/>
-          <a:lstStyle/>
-          <a:p>
-            <a:pPr algn="l" indent="0" marL="0">
-              <a:lnSpc>
-                <a:spcPct val="110000"/>
-              </a:lnSpc>
-              <a:buNone/>
-            </a:pPr>
-            <a:r>
-              <a:rPr lang="en-US" sz="1050" dirty="0">
-                <a:solidFill>
-                  <a:srgbClr val="8E8E8E"/>
-                </a:solidFill>
-                <a:latin typeface="Calibri" pitchFamily="34" charset="0"/>
-                <a:ea typeface="Calibri" pitchFamily="34" charset="-122"/>
-                <a:cs typeface="Calibri" pitchFamily="34" charset="-120"/>
-              </a:rPr>
-              <a:t>Monitoring, intervention, or reassessment started.</a:t>
-            </a:r>
-            <a:endParaRPr lang="en-US" sz="1050" dirty="0"/>
-          </a:p>
-        </p:txBody>
-      </p:sp>
-      <p:sp>
-        <p:nvSpPr>
-          <p:cNvPr id="36" name="Shape 34"/>
-          <p:cNvSpPr/>
-          <p:nvPr/>
-        </p:nvSpPr>
-        <p:spPr>
-          <a:xfrm>
-            <a:off x="4654296" y="4535424"/>
-            <a:ext cx="1792224" cy="1572768"/>
-          </a:xfrm>
-          <a:prstGeom prst="roundRect">
-            <a:avLst>
-              <a:gd name="adj" fmla="val 6977"/>
-            </a:avLst>
-          </a:prstGeom>
-          <a:solidFill>
-            <a:srgbClr val="F4F4F4"/>
-          </a:solidFill>
-          <a:ln w="12700">
-            <a:solidFill>
-              <a:srgbClr val="E6E6E6"/>
-            </a:solidFill>
-            <a:prstDash val="solid"/>
-          </a:ln>
-        </p:spPr>
-      </p:sp>
-      <p:sp>
-        <p:nvSpPr>
-          <p:cNvPr id="37" name="Text 35"/>
-          <p:cNvSpPr/>
-          <p:nvPr/>
-        </p:nvSpPr>
-        <p:spPr>
-          <a:xfrm>
-            <a:off x="4873752" y="4791456"/>
-            <a:ext cx="1389888" cy="274320"/>
-          </a:xfrm>
-          <a:prstGeom prst="rect">
-            <a:avLst/>
-          </a:prstGeom>
-          <a:noFill/>
-          <a:ln/>
-        </p:spPr>
-        <p:txBody>
-          <a:bodyPr wrap="square" lIns="0" tIns="0" rIns="0" bIns="0" rtlCol="0" anchor="t"/>
-          <a:lstStyle/>
-          <a:p>
-            <a:pPr algn="l" indent="0" marL="0">
-              <a:buNone/>
-            </a:pPr>
-            <a:r>
-              <a:rPr lang="en-US" sz="1450" b="1" dirty="0">
-                <a:solidFill>
-                  <a:srgbClr val="5A6CE6"/>
-                </a:solidFill>
-                <a:latin typeface="Calibri" pitchFamily="34" charset="0"/>
-                <a:ea typeface="Calibri" pitchFamily="34" charset="-122"/>
-                <a:cs typeface="Calibri" pitchFamily="34" charset="-120"/>
-              </a:rPr>
-              <a:t>Earlier</a:t>
-            </a:r>
-            <a:endParaRPr lang="en-US" sz="1450" dirty="0"/>
-          </a:p>
-        </p:txBody>
-      </p:sp>
-      <p:sp>
-        <p:nvSpPr>
-          <p:cNvPr id="38" name="Text 36"/>
-          <p:cNvSpPr/>
-          <p:nvPr/>
-        </p:nvSpPr>
-        <p:spPr>
-          <a:xfrm>
-            <a:off x="4873752" y="5138928"/>
-            <a:ext cx="1389888" cy="822960"/>
-          </a:xfrm>
-          <a:prstGeom prst="rect">
-            <a:avLst/>
-          </a:prstGeom>
-          <a:noFill/>
-          <a:ln/>
-        </p:spPr>
-        <p:txBody>
-          <a:bodyPr wrap="square" lIns="0" tIns="0" rIns="0" bIns="0" rtlCol="0" anchor="t"/>
-          <a:lstStyle/>
-          <a:p>
-            <a:pPr algn="l" indent="0" marL="0">
-              <a:lnSpc>
-                <a:spcPct val="110000"/>
-              </a:lnSpc>
-              <a:buNone/>
-            </a:pPr>
-            <a:r>
-              <a:rPr lang="en-US" sz="1050" dirty="0">
-                <a:solidFill>
-                  <a:srgbClr val="8E8E8E"/>
-                </a:solidFill>
-                <a:latin typeface="Calibri" pitchFamily="34" charset="0"/>
-                <a:ea typeface="Calibri" pitchFamily="34" charset="-122"/>
-                <a:cs typeface="Calibri" pitchFamily="34" charset="-120"/>
-              </a:rPr>
-              <a:t>Decline reviewed sooner, with fewer delayed reassessments.</a:t>
-            </a:r>
-            <a:endParaRPr lang="en-US" sz="1050" dirty="0"/>
-          </a:p>
-        </p:txBody>
-      </p:sp>
-      <p:sp>
-        <p:nvSpPr>
-          <p:cNvPr id="39" name="Shape 37"/>
-          <p:cNvSpPr/>
-          <p:nvPr/>
-        </p:nvSpPr>
-        <p:spPr>
-          <a:xfrm>
-            <a:off x="6702552" y="4535424"/>
-            <a:ext cx="4709160" cy="1572768"/>
-          </a:xfrm>
-          <a:prstGeom prst="roundRect">
-            <a:avLst>
-              <a:gd name="adj" fmla="val 8140"/>
+              <a:gd name="adj" fmla="val 13725"/>
             </a:avLst>
           </a:prstGeom>
           <a:solidFill>
@@ -2190,13 +2188,13 @@
       </p:sp>
       <p:sp>
         <p:nvSpPr>
-          <p:cNvPr id="40" name="Shape 38"/>
-          <p:cNvSpPr/>
-          <p:nvPr/>
-        </p:nvSpPr>
-        <p:spPr>
-          <a:xfrm>
-            <a:off x="7022592" y="4818888"/>
+          <p:cNvPr id="39" name="Shape 37"/>
+          <p:cNvSpPr/>
+          <p:nvPr/>
+        </p:nvSpPr>
+        <p:spPr>
+          <a:xfrm>
+            <a:off x="6117336" y="5330952"/>
             <a:ext cx="109728" cy="109728"/>
           </a:xfrm>
           <a:prstGeom prst="ellipse">
@@ -2210,190 +2208,190 @@
       </p:sp>
       <p:sp>
         <p:nvSpPr>
+          <p:cNvPr id="40" name="Text 38"/>
+          <p:cNvSpPr/>
+          <p:nvPr/>
+        </p:nvSpPr>
+        <p:spPr>
+          <a:xfrm>
+            <a:off x="6318504" y="5239512"/>
+            <a:ext cx="7315200" cy="292608"/>
+          </a:xfrm>
+          <a:prstGeom prst="rect">
+            <a:avLst/>
+          </a:prstGeom>
+          <a:noFill/>
+          <a:ln/>
+        </p:spPr>
+        <p:txBody>
+          <a:bodyPr wrap="square" lIns="0" tIns="0" rIns="0" bIns="0" rtlCol="0" anchor="ctr"/>
+          <a:lstStyle/>
+          <a:p>
+            <a:pPr algn="l" indent="0" marL="0">
+              <a:buNone/>
+            </a:pPr>
+            <a:r>
+              <a:rPr lang="en-US" sz="1100" b="1" spc="200" kern="0" dirty="0">
+                <a:solidFill>
+                  <a:srgbClr val="4A4458"/>
+                </a:solidFill>
+                <a:latin typeface="Calibri" pitchFamily="34" charset="0"/>
+                <a:ea typeface="Calibri" pitchFamily="34" charset="-122"/>
+                <a:cs typeface="Calibri" pitchFamily="34" charset="-120"/>
+              </a:rPr>
+              <a:t>RENEWAL STORY</a:t>
+            </a:r>
+            <a:endParaRPr lang="en-US" sz="1100" dirty="0"/>
+          </a:p>
+        </p:txBody>
+      </p:sp>
+      <p:sp>
+        <p:nvSpPr>
           <p:cNvPr id="41" name="Text 39"/>
           <p:cNvSpPr/>
           <p:nvPr/>
         </p:nvSpPr>
         <p:spPr>
           <a:xfrm>
-            <a:off x="7223760" y="4727448"/>
-            <a:ext cx="7315200" cy="292608"/>
-          </a:xfrm>
-          <a:prstGeom prst="rect">
-            <a:avLst/>
-          </a:prstGeom>
-          <a:noFill/>
-          <a:ln/>
-        </p:spPr>
-        <p:txBody>
-          <a:bodyPr wrap="square" lIns="0" tIns="0" rIns="0" bIns="0" rtlCol="0" anchor="ctr"/>
-          <a:lstStyle/>
-          <a:p>
-            <a:pPr algn="l" indent="0" marL="0">
-              <a:buNone/>
-            </a:pPr>
-            <a:r>
-              <a:rPr lang="en-US" sz="1100" b="1" spc="200" kern="0" dirty="0">
-                <a:solidFill>
-                  <a:srgbClr val="4A4458"/>
-                </a:solidFill>
-                <a:latin typeface="Calibri" pitchFamily="34" charset="0"/>
-                <a:ea typeface="Calibri" pitchFamily="34" charset="-122"/>
-                <a:cs typeface="Calibri" pitchFamily="34" charset="-120"/>
-              </a:rPr>
-              <a:t>RENEWAL STORY</a:t>
-            </a:r>
-            <a:endParaRPr lang="en-US" sz="1100" dirty="0"/>
+            <a:off x="6117336" y="5577840"/>
+            <a:ext cx="4983480" cy="457200"/>
+          </a:xfrm>
+          <a:prstGeom prst="rect">
+            <a:avLst/>
+          </a:prstGeom>
+          <a:noFill/>
+          <a:ln/>
+        </p:spPr>
+        <p:txBody>
+          <a:bodyPr wrap="square" lIns="0" tIns="0" rIns="0" bIns="0" rtlCol="0" anchor="t"/>
+          <a:lstStyle/>
+          <a:p>
+            <a:pPr algn="l" indent="0" marL="0">
+              <a:lnSpc>
+                <a:spcPct val="114000"/>
+              </a:lnSpc>
+              <a:buNone/>
+            </a:pPr>
+            <a:r>
+              <a:rPr lang="en-US" sz="1300" dirty="0">
+                <a:solidFill>
+                  <a:srgbClr val="37373C"/>
+                </a:solidFill>
+                <a:latin typeface="Calibri" pitchFamily="34" charset="0"/>
+                <a:ea typeface="Calibri" pitchFamily="34" charset="-122"/>
+                <a:cs typeface="Calibri" pitchFamily="34" charset="-120"/>
+              </a:rPr>
+              <a:t>By renewal, Teton can show </a:t>
+            </a:r>
+            <a:pPr algn="l" indent="0" marL="0">
+              <a:lnSpc>
+                <a:spcPct val="114000"/>
+              </a:lnSpc>
+              <a:buNone/>
+            </a:pPr>
+            <a:r>
+              <a:rPr lang="en-US" sz="1300" b="1" dirty="0">
+                <a:solidFill>
+                  <a:srgbClr val="181818"/>
+                </a:solidFill>
+                <a:latin typeface="Calibri" pitchFamily="34" charset="0"/>
+                <a:ea typeface="Calibri" pitchFamily="34" charset="-122"/>
+                <a:cs typeface="Calibri" pitchFamily="34" charset="-120"/>
+              </a:rPr>
+              <a:t>earlier identification</a:t>
+            </a:r>
+            <a:pPr algn="l" indent="0" marL="0">
+              <a:lnSpc>
+                <a:spcPct val="114000"/>
+              </a:lnSpc>
+              <a:buNone/>
+            </a:pPr>
+            <a:r>
+              <a:rPr lang="en-US" sz="1300" dirty="0">
+                <a:solidFill>
+                  <a:srgbClr val="37373C"/>
+                </a:solidFill>
+                <a:latin typeface="Calibri" pitchFamily="34" charset="0"/>
+                <a:ea typeface="Calibri" pitchFamily="34" charset="-122"/>
+                <a:cs typeface="Calibri" pitchFamily="34" charset="-120"/>
+              </a:rPr>
+              <a:t>, </a:t>
+            </a:r>
+            <a:pPr algn="l" indent="0" marL="0">
+              <a:lnSpc>
+                <a:spcPct val="114000"/>
+              </a:lnSpc>
+              <a:buNone/>
+            </a:pPr>
+            <a:r>
+              <a:rPr lang="en-US" sz="1300" b="1" dirty="0">
+                <a:solidFill>
+                  <a:srgbClr val="181818"/>
+                </a:solidFill>
+                <a:latin typeface="Calibri" pitchFamily="34" charset="0"/>
+                <a:ea typeface="Calibri" pitchFamily="34" charset="-122"/>
+                <a:cs typeface="Calibri" pitchFamily="34" charset="-120"/>
+              </a:rPr>
+              <a:t>documented reassessments</a:t>
+            </a:r>
+            <a:pPr algn="l" indent="0" marL="0">
+              <a:lnSpc>
+                <a:spcPct val="114000"/>
+              </a:lnSpc>
+              <a:buNone/>
+            </a:pPr>
+            <a:r>
+              <a:rPr lang="en-US" sz="1300" dirty="0">
+                <a:solidFill>
+                  <a:srgbClr val="37373C"/>
+                </a:solidFill>
+                <a:latin typeface="Calibri" pitchFamily="34" charset="0"/>
+                <a:ea typeface="Calibri" pitchFamily="34" charset="-122"/>
+                <a:cs typeface="Calibri" pitchFamily="34" charset="-120"/>
+              </a:rPr>
+              <a:t>, and an </a:t>
+            </a:r>
+            <a:pPr algn="l" indent="0" marL="0">
+              <a:lnSpc>
+                <a:spcPct val="114000"/>
+              </a:lnSpc>
+              <a:buNone/>
+            </a:pPr>
+            <a:r>
+              <a:rPr lang="en-US" sz="1300" b="1" dirty="0">
+                <a:solidFill>
+                  <a:srgbClr val="181818"/>
+                </a:solidFill>
+                <a:latin typeface="Calibri" pitchFamily="34" charset="0"/>
+                <a:ea typeface="Calibri" pitchFamily="34" charset="-122"/>
+                <a:cs typeface="Calibri" pitchFamily="34" charset="-120"/>
+              </a:rPr>
+              <a:t>ROI story beyond falls</a:t>
+            </a:r>
+            <a:pPr algn="l" indent="0" marL="0">
+              <a:lnSpc>
+                <a:spcPct val="114000"/>
+              </a:lnSpc>
+              <a:buNone/>
+            </a:pPr>
+            <a:r>
+              <a:rPr lang="en-US" sz="1300" dirty="0">
+                <a:solidFill>
+                  <a:srgbClr val="37373C"/>
+                </a:solidFill>
+                <a:latin typeface="Calibri" pitchFamily="34" charset="0"/>
+                <a:ea typeface="Calibri" pitchFamily="34" charset="-122"/>
+                <a:cs typeface="Calibri" pitchFamily="34" charset="-120"/>
+              </a:rPr>
+              <a:t>.</a:t>
+            </a:r>
+            <a:endParaRPr lang="en-US" sz="1300" dirty="0"/>
           </a:p>
         </p:txBody>
       </p:sp>
       <p:sp>
         <p:nvSpPr>
           <p:cNvPr id="42" name="Text 40"/>
-          <p:cNvSpPr/>
-          <p:nvPr/>
-        </p:nvSpPr>
-        <p:spPr>
-          <a:xfrm>
-            <a:off x="7022592" y="5138928"/>
-            <a:ext cx="4069080" cy="914400"/>
-          </a:xfrm>
-          <a:prstGeom prst="rect">
-            <a:avLst/>
-          </a:prstGeom>
-          <a:noFill/>
-          <a:ln/>
-        </p:spPr>
-        <p:txBody>
-          <a:bodyPr wrap="square" lIns="0" tIns="0" rIns="0" bIns="0" rtlCol="0" anchor="t"/>
-          <a:lstStyle/>
-          <a:p>
-            <a:pPr algn="l" indent="0" marL="0">
-              <a:lnSpc>
-                <a:spcPct val="116000"/>
-              </a:lnSpc>
-              <a:buNone/>
-            </a:pPr>
-            <a:r>
-              <a:rPr lang="en-US" sz="1450" dirty="0">
-                <a:solidFill>
-                  <a:srgbClr val="37373C"/>
-                </a:solidFill>
-                <a:latin typeface="Calibri" pitchFamily="34" charset="0"/>
-                <a:ea typeface="Calibri" pitchFamily="34" charset="-122"/>
-                <a:cs typeface="Calibri" pitchFamily="34" charset="-120"/>
-              </a:rPr>
-              <a:t>By renewal, Teton can show </a:t>
-            </a:r>
-            <a:pPr algn="l" indent="0" marL="0">
-              <a:lnSpc>
-                <a:spcPct val="116000"/>
-              </a:lnSpc>
-              <a:buNone/>
-            </a:pPr>
-            <a:r>
-              <a:rPr lang="en-US" sz="1450" b="1" dirty="0">
-                <a:solidFill>
-                  <a:srgbClr val="181818"/>
-                </a:solidFill>
-                <a:latin typeface="Calibri" pitchFamily="34" charset="0"/>
-                <a:ea typeface="Calibri" pitchFamily="34" charset="-122"/>
-                <a:cs typeface="Calibri" pitchFamily="34" charset="-120"/>
-              </a:rPr>
-              <a:t>earlier resident identification</a:t>
-            </a:r>
-            <a:pPr algn="l" indent="0" marL="0">
-              <a:lnSpc>
-                <a:spcPct val="116000"/>
-              </a:lnSpc>
-              <a:buNone/>
-            </a:pPr>
-            <a:r>
-              <a:rPr lang="en-US" sz="1450" dirty="0">
-                <a:solidFill>
-                  <a:srgbClr val="37373C"/>
-                </a:solidFill>
-                <a:latin typeface="Calibri" pitchFamily="34" charset="0"/>
-                <a:ea typeface="Calibri" pitchFamily="34" charset="-122"/>
-                <a:cs typeface="Calibri" pitchFamily="34" charset="-120"/>
-              </a:rPr>
-              <a:t>, </a:t>
-            </a:r>
-            <a:pPr algn="l" indent="0" marL="0">
-              <a:lnSpc>
-                <a:spcPct val="116000"/>
-              </a:lnSpc>
-              <a:buNone/>
-            </a:pPr>
-            <a:r>
-              <a:rPr lang="en-US" sz="1450" b="1" dirty="0">
-                <a:solidFill>
-                  <a:srgbClr val="181818"/>
-                </a:solidFill>
-                <a:latin typeface="Calibri" pitchFamily="34" charset="0"/>
-                <a:ea typeface="Calibri" pitchFamily="34" charset="-122"/>
-                <a:cs typeface="Calibri" pitchFamily="34" charset="-120"/>
-              </a:rPr>
-              <a:t>documented reassessments</a:t>
-            </a:r>
-            <a:pPr algn="l" indent="0" marL="0">
-              <a:lnSpc>
-                <a:spcPct val="116000"/>
-              </a:lnSpc>
-              <a:buNone/>
-            </a:pPr>
-            <a:r>
-              <a:rPr lang="en-US" sz="1450" dirty="0">
-                <a:solidFill>
-                  <a:srgbClr val="37373C"/>
-                </a:solidFill>
-                <a:latin typeface="Calibri" pitchFamily="34" charset="0"/>
-                <a:ea typeface="Calibri" pitchFamily="34" charset="-122"/>
-                <a:cs typeface="Calibri" pitchFamily="34" charset="-120"/>
-              </a:rPr>
-              <a:t>, and a </a:t>
-            </a:r>
-            <a:pPr algn="l" indent="0" marL="0">
-              <a:lnSpc>
-                <a:spcPct val="116000"/>
-              </a:lnSpc>
-              <a:buNone/>
-            </a:pPr>
-            <a:r>
-              <a:rPr lang="en-US" sz="1450" b="1" dirty="0">
-                <a:solidFill>
-                  <a:srgbClr val="181818"/>
-                </a:solidFill>
-                <a:latin typeface="Calibri" pitchFamily="34" charset="0"/>
-                <a:ea typeface="Calibri" pitchFamily="34" charset="-122"/>
-                <a:cs typeface="Calibri" pitchFamily="34" charset="-120"/>
-              </a:rPr>
-              <a:t>care-quality ROI story beyond falls</a:t>
-            </a:r>
-            <a:pPr algn="l" indent="0" marL="0">
-              <a:lnSpc>
-                <a:spcPct val="116000"/>
-              </a:lnSpc>
-              <a:buNone/>
-            </a:pPr>
-            <a:r>
-              <a:rPr lang="en-US" sz="1450" dirty="0">
-                <a:solidFill>
-                  <a:srgbClr val="37373C"/>
-                </a:solidFill>
-                <a:latin typeface="Calibri" pitchFamily="34" charset="0"/>
-                <a:ea typeface="Calibri" pitchFamily="34" charset="-122"/>
-                <a:cs typeface="Calibri" pitchFamily="34" charset="-120"/>
-              </a:rPr>
-              <a:t>.</a:t>
-            </a:r>
-            <a:endParaRPr lang="en-US" sz="1450" dirty="0"/>
-          </a:p>
-        </p:txBody>
-      </p:sp>
-      <p:sp>
-        <p:nvSpPr>
-          <p:cNvPr id="43" name="Text 41"/>
           <p:cNvSpPr/>
           <p:nvPr/>
         </p:nvSpPr>
@@ -2432,7 +2430,7 @@
       </p:sp>
       <p:sp>
         <p:nvSpPr>
-          <p:cNvPr id="44" name="Text 42"/>
+          <p:cNvPr id="43" name="Text 41"/>
           <p:cNvSpPr/>
           <p:nvPr/>
         </p:nvSpPr>

</xml_diff>